<commit_message>
Expand academic report docx and add doc audit verification script
</commit_message>
<xml_diff>
--- a/artifacts/project_presentation.pptx
+++ b/artifacts/project_presentation.pptx
@@ -3389,7 +3389,7 @@
               </a:defRPr>
             </a:pPr>
             <a:r>
-              <a:t>• Execution Time: 1.54 seconds across 5 test modules.</a:t>
+              <a:t>• Execution Time: 0.57 seconds across 5 test modules.</a:t>
             </a:r>
           </a:p>
           <a:p>
@@ -3785,7 +3785,7 @@
               </a:defRPr>
             </a:pPr>
             <a:r>
-              <a:t>• ChromaDB / pgvector integration for multi-page PDF RAG.</a:t>
+              <a:t>• ChromaDB / pgvector integration for multi-page textbook RAG.</a:t>
             </a:r>
           </a:p>
           <a:p>

</xml_diff>

<commit_message>
Format 5 separated team roll numbers and remove institutional and date placeholders
</commit_message>
<xml_diff>
--- a/artifacts/project_presentation.pptx
+++ b/artifacts/project_presentation.pptx
@@ -3195,18 +3195,34 @@
           <a:p>
             <a:br/>
             <a:pPr>
-              <a:defRPr sz="1500">
-                <a:solidFill>
-                  <a:srgbClr val="B4C8DC"/>
-                </a:solidFill>
-              </a:defRPr>
-            </a:pPr>
-            <a:r>
-              <a:t>Students: G. Rakesh Kumar and M.Harshitha  |  ID: [STUDENT_ID]</a:t>
+              <a:defRPr sz="1300">
+                <a:solidFill>
+                  <a:srgbClr val="B4D2EB"/>
+                </a:solidFill>
+              </a:defRPr>
+            </a:pPr>
+            <a:r>
+              <a:t>Project Team &amp; Roll Numbers:</a:t>
             </a:r>
             <a:br/>
             <a:r>
-              <a:t>Institution: [INSTITUTION_NAME]  |  Evaluation Date: [SUBMISSION_DATE]</a:t>
+              <a:t>• G. Rakesh Kumar (Roll No: [ROLL_NO_1])</a:t>
+            </a:r>
+            <a:br/>
+            <a:r>
+              <a:t>• M. Harshitha (Roll No: [ROLL_NO_2])</a:t>
+            </a:r>
+            <a:br/>
+            <a:r>
+              <a:t>• Team Member 3 (Roll No: [ROLL_NO_3])</a:t>
+            </a:r>
+            <a:br/>
+            <a:r>
+              <a:t>• Team Member 4 (Roll No: [ROLL_NO_4])</a:t>
+            </a:r>
+            <a:br/>
+            <a:r>
+              <a:t>• Team Member 5 (Roll No: [ROLL_NO_5])</a:t>
             </a:r>
           </a:p>
         </p:txBody>

</xml_diff>

<commit_message>
Remove roll numbers from final submission documents
</commit_message>
<xml_diff>
--- a/artifacts/project_presentation.pptx
+++ b/artifacts/project_presentation.pptx
@@ -3195,34 +3195,18 @@
           <a:p>
             <a:br/>
             <a:pPr>
-              <a:defRPr sz="1300">
+              <a:defRPr sz="1600" b="1">
                 <a:solidFill>
                   <a:srgbClr val="B4D2EB"/>
                 </a:solidFill>
               </a:defRPr>
             </a:pPr>
             <a:r>
-              <a:t>Project Team &amp; Roll Numbers:</a:t>
+              <a:t>Team: Team Number 22</a:t>
             </a:r>
             <a:br/>
             <a:r>
-              <a:t>• G. Rakesh Kumar (Roll No: [ROLL_NO_1])</a:t>
-            </a:r>
-            <a:br/>
-            <a:r>
-              <a:t>• M. Harshitha (Roll No: [ROLL_NO_2])</a:t>
-            </a:r>
-            <a:br/>
-            <a:r>
-              <a:t>• Team Member 3 (Roll No: [ROLL_NO_3])</a:t>
-            </a:r>
-            <a:br/>
-            <a:r>
-              <a:t>• Team Member 4 (Roll No: [ROLL_NO_4])</a:t>
-            </a:r>
-            <a:br/>
-            <a:r>
-              <a:t>• Team Member 5 (Roll No: [ROLL_NO_5])</a:t>
+              <a:t>Course: Agentic AI Systems &amp; Engineering</a:t>
             </a:r>
           </a:p>
         </p:txBody>

</xml_diff>